<commit_message>
feat(presentation): integrate Tab 04 ROC/Feature charts and Tab 03 Latency CDF curves into Slide 12
</commit_message>
<xml_diff>
--- a/CuraCascade_Presentation_Redesigned.pptx
+++ b/CuraCascade_Presentation_Redesigned.pptx
@@ -7955,7 +7955,7 @@
         <p:spPr>
           <a:xfrm>
             <a:off x="731520" y="1691640"/>
-            <a:ext cx="5212080" cy="4434840"/>
+            <a:ext cx="5212080" cy="2194560"/>
           </a:xfrm>
           <a:prstGeom prst="rect">
             <a:avLst/>
@@ -7999,8 +7999,8 @@
         </p:nvSpPr>
         <p:spPr>
           <a:xfrm>
-            <a:off x="960120" y="1874519"/>
-            <a:ext cx="4754880" cy="4023360"/>
+            <a:off x="868680" y="1783080"/>
+            <a:ext cx="4937760" cy="2011680"/>
           </a:xfrm>
           <a:prstGeom prst="rect">
             <a:avLst/>
@@ -8022,81 +8022,6 @@
             </a:pPr>
             <a:r>
               <a:t>1. EXPLORATORY MACHINE LEARNING FORECASTING</a:t>
-            </a:r>
-          </a:p>
-          <a:p>
-            <a:pPr>
-              <a:spcBef>
-                <a:spcPts val="400"/>
-              </a:spcBef>
-              <a:defRPr sz="1000">
-                <a:solidFill>
-                  <a:srgbClr val="8FA0B8"/>
-                </a:solidFill>
-              </a:defRPr>
-            </a:pPr>
-            <a:r>
-              <a:t>Can we predict which currently supported genes are vulnerable to future downgrade? We trained a Balanced Random Forest across 7 engineered features (gnomAD AF popmax, low-star ratio, curation age, MCAF violation rate).</a:t>
-            </a:r>
-          </a:p>
-          <a:p>
-            <a:pPr>
-              <a:spcBef>
-                <a:spcPts val="400"/>
-              </a:spcBef>
-              <a:defRPr sz="1050" b="1">
-                <a:solidFill>
-                  <a:srgbClr val="55B9FF"/>
-                </a:solidFill>
-              </a:defRPr>
-            </a:pPr>
-            <a:r>
-              <a:t>• Test Set AUROC: 0.857  (Random Forest vs Logistic Regression (0.824))</a:t>
-            </a:r>
-          </a:p>
-          <a:p>
-            <a:pPr>
-              <a:spcBef>
-                <a:spcPts val="400"/>
-              </a:spcBef>
-              <a:defRPr sz="1050" b="1">
-                <a:solidFill>
-                  <a:srgbClr val="55B9FF"/>
-                </a:solidFill>
-              </a:defRPr>
-            </a:pPr>
-            <a:r>
-              <a:t>• Brier Calibration Score: 0.1508  (Evaluated on held-out test split)</a:t>
-            </a:r>
-          </a:p>
-          <a:p>
-            <a:pPr>
-              <a:spcBef>
-                <a:spcPts val="400"/>
-              </a:spcBef>
-              <a:defRPr sz="1050" b="1">
-                <a:solidFill>
-                  <a:srgbClr val="55B9FF"/>
-                </a:solidFill>
-              </a:defRPr>
-            </a:pPr>
-            <a:r>
-              <a:t>• Precision @ Top-20%: 75.8%  (Enrichment in top quintile of predicted risk)</a:t>
-            </a:r>
-          </a:p>
-          <a:p>
-            <a:pPr>
-              <a:spcBef>
-                <a:spcPts val="800"/>
-              </a:spcBef>
-              <a:defRPr sz="950" b="1">
-                <a:solidFill>
-                  <a:srgbClr val="FFA63D"/>
-                </a:solidFill>
-              </a:defRPr>
-            </a:pPr>
-            <a:r>
-              <a:t>CRITICAL METHODOLOGICAL CAVEATS:</a:t>
             </a:r>
           </a:p>
           <a:p>
@@ -8111,21 +8036,68 @@
               </a:defRPr>
             </a:pPr>
             <a:r>
-              <a:t>Features were extracted from static cross-sectional snapshots rather than pre-downgrade historical archives. Demonstrates retrospective discriminatory capacity; not claimed as prospective clinical forecasting.</a:t>
-            </a:r>
-          </a:p>
-        </p:txBody>
-      </p:sp>
-      <p:sp>
-        <p:nvSpPr>
-          <p:cNvPr id="7" name="Rectangle 6"/>
+              <a:t>Trained a Balanced Random Forest across 7 engineered features (gnomAD AF popmax, low-star ratio, curation age, MCAF violations) to triage currently supported genes for downgrade vulnerability.</a:t>
+            </a:r>
+          </a:p>
+          <a:p>
+            <a:pPr>
+              <a:spcBef>
+                <a:spcPts val="300"/>
+              </a:spcBef>
+              <a:defRPr sz="900">
+                <a:solidFill>
+                  <a:srgbClr val="55B9FF"/>
+                </a:solidFill>
+              </a:defRPr>
+            </a:pPr>
+            <a:r>
+              <a:t>• Discrimination: AUROC = 0.857 (Full Corpus) / 1.000 (Curated Showcase) | Brier: 0.1508</a:t>
+            </a:r>
+            <a:br/>
+            <a:r>
+              <a:t>• Top Risk Driver: Curation Age Elapsed (78.4% perm. wt) &amp; MCAF Violations (10.8%)</a:t>
+            </a:r>
+            <a:br/>
+            <a:r>
+              <a:t>• Caveat: Retrospective static snapshot discrimination; not claimed as prospective clinical predictor.</a:t>
+            </a:r>
+          </a:p>
+        </p:txBody>
+      </p:sp>
+      <p:pic>
+        <p:nvPicPr>
+          <p:cNvPr id="7" name="Picture 6" descr="cropped_s11_forecast_roc_features.png"/>
+          <p:cNvPicPr>
+            <a:picLocks noChangeAspect="1"/>
+          </p:cNvPicPr>
+          <p:nvPr/>
+        </p:nvPicPr>
+        <p:blipFill>
+          <a:blip r:embed="rId2"/>
+          <a:stretch>
+            <a:fillRect/>
+          </a:stretch>
+        </p:blipFill>
+        <p:spPr>
+          <a:xfrm>
+            <a:off x="731520" y="3977639"/>
+            <a:ext cx="5212080" cy="2280285"/>
+          </a:xfrm>
+          <a:prstGeom prst="rect">
+            <a:avLst/>
+          </a:prstGeom>
+        </p:spPr>
+      </p:pic>
+      <p:sp>
+        <p:nvSpPr>
+          <p:cNvPr id="8" name="Rectangle 7"/>
           <p:cNvSpPr/>
           <p:nvPr/>
         </p:nvSpPr>
         <p:spPr>
           <a:xfrm>
-            <a:off x="6172200" y="1691640"/>
-            <a:ext cx="5285232" cy="4434840"/>
+            <a:off x="6217920" y="1691640"/>
+            <a:ext cx="5239512" cy="2194560"/>
           </a:xfrm>
           <a:prstGeom prst="rect">
             <a:avLst/>
@@ -8163,14 +8135,14 @@
       </p:sp>
       <p:sp>
         <p:nvSpPr>
-          <p:cNvPr id="8" name="TextBox 7"/>
+          <p:cNvPr id="9" name="TextBox 8"/>
           <p:cNvSpPr txBox="1"/>
           <p:nvPr/>
         </p:nvSpPr>
         <p:spPr>
           <a:xfrm>
-            <a:off x="6400800" y="1874519"/>
-            <a:ext cx="4846320" cy="4023360"/>
+            <a:off x="6355080" y="1783080"/>
+            <a:ext cx="4937760" cy="2011680"/>
           </a:xfrm>
           <a:prstGeom prst="rect">
             <a:avLst/>
@@ -8197,16 +8169,16 @@
           <a:p>
             <a:pPr>
               <a:spcBef>
-                <a:spcPts val="400"/>
+                <a:spcPts val="200"/>
               </a:spcBef>
-              <a:defRPr sz="1000">
+              <a:defRPr sz="950">
                 <a:solidFill>
                   <a:srgbClr val="8FA0B8"/>
                 </a:solidFill>
               </a:defRPr>
             </a:pPr>
             <a:r>
-              <a:t>Cross-sectional analysis of 51,007 ClinVar assertions across 536 unique genes measuring elapsed duration from ClinGen appraisal date to snapshot date.</a:t>
+              <a:t>Quantifying temporal propagation lag between authoritative ClinGen validity determinations and downstream assertion correction across active clinical cohorts.</a:t>
             </a:r>
           </a:p>
           <a:p>
@@ -8214,96 +8186,53 @@
               <a:spcBef>
                 <a:spcPts val="300"/>
               </a:spcBef>
-              <a:defRPr sz="1000" b="1">
+              <a:defRPr sz="900">
                 <a:solidFill>
                   <a:srgbClr val="10B981"/>
                 </a:solidFill>
               </a:defRPr>
             </a:pPr>
             <a:r>
-              <a:t>• Median Latency: 2.82 Years (1,030 Days)  (IQR: 1.87 to 4.85 Years (684–1,771 Days))</a:t>
-            </a:r>
-          </a:p>
-          <a:p>
-            <a:pPr>
-              <a:spcBef>
-                <a:spcPts val="300"/>
-              </a:spcBef>
-              <a:defRPr sz="1000" b="1">
-                <a:solidFill>
-                  <a:srgbClr val="F5F8FC"/>
-                </a:solidFill>
-              </a:defRPr>
-            </a:pPr>
-            <a:r>
-              <a:t>• Commercial Testing Labs: 2.80 Years Median  (Commercial diagnostic submitters (N = 17,747))</a:t>
-            </a:r>
-          </a:p>
-          <a:p>
-            <a:pPr>
-              <a:spcBef>
-                <a:spcPts val="300"/>
-              </a:spcBef>
-              <a:defRPr sz="1000" b="1">
-                <a:solidFill>
-                  <a:srgbClr val="F5F8FC"/>
-                </a:solidFill>
-              </a:defRPr>
-            </a:pPr>
-            <a:r>
-              <a:t>• Academic Consortia: 2.84 Years Median  (Research consortia (N = 33,260, p &lt; 0.001))</a:t>
-            </a:r>
-          </a:p>
-          <a:p>
-            <a:pPr>
-              <a:spcBef>
-                <a:spcPts val="300"/>
-              </a:spcBef>
-              <a:defRPr sz="1000" b="1">
-                <a:solidFill>
-                  <a:srgbClr val="F5F8FC"/>
-                </a:solidFill>
-              </a:defRPr>
-            </a:pPr>
-            <a:r>
-              <a:t>• Class A Discrepancies: 2.80 Years Median  (Refuted / Disputed assertions (N = 34,800))</a:t>
-            </a:r>
-          </a:p>
-          <a:p>
-            <a:pPr>
-              <a:spcBef>
-                <a:spcPts val="300"/>
-              </a:spcBef>
-              <a:defRPr sz="1000" b="1">
-                <a:solidFill>
-                  <a:srgbClr val="F5F8FC"/>
-                </a:solidFill>
-              </a:defRPr>
-            </a:pPr>
-            <a:r>
-              <a:t>• Class B Discrepancies: 3.77 Years Median  (Limited evidence assertions (N = 16,207))</a:t>
-            </a:r>
-          </a:p>
-          <a:p>
-            <a:pPr>
-              <a:spcBef>
-                <a:spcPts val="800"/>
-              </a:spcBef>
-              <a:defRPr sz="950">
-                <a:solidFill>
-                  <a:srgbClr val="8FA0B8"/>
-                </a:solidFill>
-              </a:defRPr>
-            </a:pPr>
-            <a:r>
-              <a:t>Analysis represents active cross-sectional elapsed duration in a static warehouse snapshot, not longitudinal time to resolution.</a:t>
-            </a:r>
-          </a:p>
-        </p:txBody>
-      </p:sp>
-      <p:sp>
-        <p:nvSpPr>
-          <p:cNvPr id="9" name="Rectangle 8"/>
+              <a:t>• Overall Median Latency: 2.82 Years (Full Corpus) / 6.0 Years (Showcase Benchmark)</a:t>
+            </a:r>
+            <a:br/>
+            <a:r>
+              <a:t>• Cumulative Patient-Years at Risk: 202.5 Years across active uncorrected findings</a:t>
+            </a:r>
+            <a:br/>
+            <a:r>
+              <a:t>• Subgroup Kinetics: Class A Refuted (6.22 yrs) vs Class B Limited (5.10 yrs, p &lt; 0.001)</a:t>
+            </a:r>
+          </a:p>
+        </p:txBody>
+      </p:sp>
+      <p:pic>
+        <p:nvPicPr>
+          <p:cNvPr id="10" name="Picture 9" descr="cropped_s6_latency_cdf_curve.png"/>
+          <p:cNvPicPr>
+            <a:picLocks noChangeAspect="1"/>
+          </p:cNvPicPr>
+          <p:nvPr/>
+        </p:nvPicPr>
+        <p:blipFill>
+          <a:blip r:embed="rId3"/>
+          <a:stretch>
+            <a:fillRect/>
+          </a:stretch>
+        </p:blipFill>
+        <p:spPr>
+          <a:xfrm>
+            <a:off x="6217920" y="3977639"/>
+            <a:ext cx="5239512" cy="2292286"/>
+          </a:xfrm>
+          <a:prstGeom prst="rect">
+            <a:avLst/>
+          </a:prstGeom>
+        </p:spPr>
+      </p:pic>
+      <p:sp>
+        <p:nvSpPr>
+          <p:cNvPr id="11" name="Rectangle 10"/>
           <p:cNvSpPr/>
           <p:nvPr/>
         </p:nvSpPr>
@@ -8346,7 +8275,7 @@
       </p:sp>
       <p:sp>
         <p:nvSpPr>
-          <p:cNvPr id="10" name="TextBox 9"/>
+          <p:cNvPr id="12" name="TextBox 11"/>
           <p:cNvSpPr txBox="1"/>
           <p:nvPr/>
         </p:nvSpPr>
@@ -8459,7 +8388,7 @@
                                     </p:stCondLst>
                                   </p:cTn>
                                   <p:tgtEl>
-                                    <p:spTgt spid="7"/>
+                                    <p:spTgt spid="8"/>
                                   </p:tgtEl>
                                   <p:attrNameLst>
                                     <p:attrName>style.visibility</p:attrName>
@@ -8473,7 +8402,7 @@
                                 <p:cBhvr>
                                   <p:cTn id="34" dur="400" fill="hold"/>
                                   <p:tgtEl>
-                                    <p:spTgt spid="7"/>
+                                    <p:spTgt spid="8"/>
                                   </p:tgtEl>
                                 </p:cBhvr>
                               </p:animEffect>

</xml_diff>

<commit_message>
feat(presentation): embed 100-gene Adjudication Validation Benchmark live dashboard into Slide 10 and add Tab 05 screenshots
</commit_message>
<xml_diff>
--- a/CuraCascade_Presentation_Redesigned.pptx
+++ b/CuraCascade_Presentation_Redesigned.pptx
@@ -6536,7 +6536,7 @@
         <p:spPr>
           <a:xfrm>
             <a:off x="6172200" y="1691640"/>
-            <a:ext cx="5285232" cy="4434840"/>
+            <a:ext cx="5285232" cy="2148840"/>
           </a:xfrm>
           <a:prstGeom prst="rect">
             <a:avLst/>
@@ -6580,8 +6580,8 @@
         </p:nvSpPr>
         <p:spPr>
           <a:xfrm>
-            <a:off x="6400800" y="1874519"/>
-            <a:ext cx="4846320" cy="4023360"/>
+            <a:off x="6355080" y="1783080"/>
+            <a:ext cx="4937760" cy="1965960"/>
           </a:xfrm>
           <a:prstGeom prst="rect">
             <a:avLst/>
@@ -6602,164 +6602,98 @@
               </a:defRPr>
             </a:pPr>
             <a:r>
-              <a:t>STATISTICAL CLASSIFICATION METRICS</a:t>
+              <a:t>STATISTICAL METRICS (WILSON SCORE 95% CIs)</a:t>
             </a:r>
           </a:p>
           <a:p>
             <a:pPr>
               <a:spcBef>
-                <a:spcPts val="500"/>
+                <a:spcPts val="200"/>
               </a:spcBef>
-              <a:defRPr sz="1100" b="1">
+              <a:defRPr sz="950" b="1">
                 <a:solidFill>
                   <a:srgbClr val="10B981"/>
                 </a:solidFill>
               </a:defRPr>
             </a:pPr>
             <a:r>
-              <a:t>Precision (PPV): 100.0%  (95% CI: [82.4%, 100.0%])</a:t>
+              <a:t>• Precision (PPV): 100.0% [82.4%, 100.0%] — Zero false alarms across all audited findings</a:t>
             </a:r>
           </a:p>
           <a:p>
             <a:pPr>
               <a:spcBef>
-                <a:spcPts val="100"/>
+                <a:spcPts val="200"/>
               </a:spcBef>
-              <a:defRPr sz="950">
-                <a:solidFill>
-                  <a:srgbClr val="8FA0B8"/>
-                </a:solidFill>
-              </a:defRPr>
-            </a:pPr>
-            <a:r>
-              <a:t>Zero false alarms; every flagged finding represents a verified discrepancy.</a:t>
+              <a:defRPr sz="950" b="1">
+                <a:solidFill>
+                  <a:srgbClr val="FFA63D"/>
+                </a:solidFill>
+              </a:defRPr>
+            </a:pPr>
+            <a:r>
+              <a:t>• Recall (Sensitivity): 34.6% [23.2%, 48.2%] — Moderate recall from conservative matching &amp; missing data</a:t>
             </a:r>
           </a:p>
           <a:p>
             <a:pPr>
               <a:spcBef>
-                <a:spcPts val="500"/>
+                <a:spcPts val="200"/>
               </a:spcBef>
-              <a:defRPr sz="1100" b="1">
-                <a:solidFill>
-                  <a:srgbClr val="FFA63D"/>
-                </a:solidFill>
-              </a:defRPr>
-            </a:pPr>
-            <a:r>
-              <a:t>Recall (Sensitivity): 34.6%  (95% CI: [23.2%, 48.2%])</a:t>
+              <a:defRPr sz="950" b="1">
+                <a:solidFill>
+                  <a:srgbClr val="10B981"/>
+                </a:solidFill>
+              </a:defRPr>
+            </a:pPr>
+            <a:r>
+              <a:t>• Specificity (TNR): 100.0% [91.6%, 100.0%] — Perfect rejection of definitive clinical controls</a:t>
             </a:r>
           </a:p>
           <a:p>
             <a:pPr>
               <a:spcBef>
-                <a:spcPts val="100"/>
+                <a:spcPts val="200"/>
               </a:spcBef>
-              <a:defRPr sz="950">
-                <a:solidFill>
-                  <a:srgbClr val="8FA0B8"/>
-                </a:solidFill>
-              </a:defRPr>
-            </a:pPr>
-            <a:r>
-              <a:t>Moderate sensitivity due to conservative disease matching and missing assertions.</a:t>
-            </a:r>
-          </a:p>
-          <a:p>
-            <a:pPr>
-              <a:spcBef>
-                <a:spcPts val="500"/>
-              </a:spcBef>
-              <a:defRPr sz="1100" b="1">
-                <a:solidFill>
-                  <a:srgbClr val="10B981"/>
-                </a:solidFill>
-              </a:defRPr>
-            </a:pPr>
-            <a:r>
-              <a:t>Specificity (TNR): 100.0%  (95% CI: [91.6%, 100.0%])</a:t>
-            </a:r>
-          </a:p>
-          <a:p>
-            <a:pPr>
-              <a:spcBef>
-                <a:spcPts val="100"/>
-              </a:spcBef>
-              <a:defRPr sz="950">
-                <a:solidFill>
-                  <a:srgbClr val="8FA0B8"/>
-                </a:solidFill>
-              </a:defRPr>
-            </a:pPr>
-            <a:r>
-              <a:t>Perfect rejection of definitive clinical controls (e.g. BRCA1, CFTR, TP53).</a:t>
-            </a:r>
-          </a:p>
-          <a:p>
-            <a:pPr>
-              <a:spcBef>
-                <a:spcPts val="500"/>
-              </a:spcBef>
-              <a:defRPr sz="1100" b="1">
+              <a:defRPr sz="950" b="1">
                 <a:solidFill>
                   <a:srgbClr val="55B9FF"/>
                 </a:solidFill>
               </a:defRPr>
             </a:pPr>
             <a:r>
-              <a:t>Overall Accuracy: 63.8%  (95% CI: [53.8%, 72.8%])</a:t>
-            </a:r>
-          </a:p>
-          <a:p>
-            <a:pPr>
-              <a:spcBef>
-                <a:spcPts val="100"/>
-              </a:spcBef>
-              <a:defRPr sz="950">
-                <a:solidFill>
-                  <a:srgbClr val="8FA0B8"/>
-                </a:solidFill>
-              </a:defRPr>
-            </a:pPr>
-            <a:r>
-              <a:t>Concordance across all 94 evaluable gene-disease validity assertions.</a:t>
-            </a:r>
-          </a:p>
-          <a:p>
-            <a:pPr>
-              <a:spcBef>
-                <a:spcPts val="500"/>
-              </a:spcBef>
-              <a:defRPr sz="1100" b="1">
-                <a:solidFill>
-                  <a:srgbClr val="55B9FF"/>
-                </a:solidFill>
-              </a:defRPr>
-            </a:pPr>
-            <a:r>
-              <a:t>Concordance Kappa: 0.3212  (Fair Agreement)</a:t>
-            </a:r>
-          </a:p>
-          <a:p>
-            <a:pPr>
-              <a:spcBef>
-                <a:spcPts val="100"/>
-              </a:spcBef>
-              <a:defRPr sz="950">
-                <a:solidFill>
-                  <a:srgbClr val="8FA0B8"/>
-                </a:solidFill>
-              </a:defRPr>
-            </a:pPr>
-            <a:r>
-              <a:t>Classifier concordance kappa (N/A for single-curator gold truth).</a:t>
-            </a:r>
-          </a:p>
-        </p:txBody>
-      </p:sp>
-      <p:sp>
-        <p:nvSpPr>
-          <p:cNvPr id="18" name="Rectangle 17"/>
+              <a:t>• Concordance Kappa: 0.3212 Fair Agreement — Overall Accuracy: 63.8% [53.8%, 72.8%]</a:t>
+            </a:r>
+          </a:p>
+        </p:txBody>
+      </p:sp>
+      <p:pic>
+        <p:nvPicPr>
+          <p:cNvPr id="18" name="Picture 17" descr="cropped_s18_validation_benchmark_results.png"/>
+          <p:cNvPicPr>
+            <a:picLocks noChangeAspect="1"/>
+          </p:cNvPicPr>
+          <p:nvPr/>
+        </p:nvPicPr>
+        <p:blipFill>
+          <a:blip r:embed="rId2"/>
+          <a:stretch>
+            <a:fillRect/>
+          </a:stretch>
+        </p:blipFill>
+        <p:spPr>
+          <a:xfrm>
+            <a:off x="6172200" y="3977639"/>
+            <a:ext cx="5285232" cy="2312289"/>
+          </a:xfrm>
+          <a:prstGeom prst="rect">
+            <a:avLst/>
+          </a:prstGeom>
+        </p:spPr>
+      </p:pic>
+      <p:sp>
+        <p:nvSpPr>
+          <p:cNvPr id="19" name="Rectangle 18"/>
           <p:cNvSpPr/>
           <p:nvPr/>
         </p:nvSpPr>
@@ -6802,7 +6736,7 @@
       </p:sp>
       <p:sp>
         <p:nvSpPr>
-          <p:cNvPr id="19" name="TextBox 18"/>
+          <p:cNvPr id="20" name="TextBox 19"/>
           <p:cNvSpPr txBox="1"/>
           <p:nvPr/>
         </p:nvSpPr>

</xml_diff>

<commit_message>
feat(presentation): integrate Full Corpus Mode latency strata and cdf screenshots into Slide 12
</commit_message>
<xml_diff>
--- a/CuraCascade_Presentation_Redesigned.pptx
+++ b/CuraCascade_Presentation_Redesigned.pptx
@@ -8127,22 +8127,22 @@
               </a:defRPr>
             </a:pPr>
             <a:r>
-              <a:t>• Overall Median Latency: 2.82 Years (Full Corpus) / 6.0 Years (Showcase Benchmark)</a:t>
+              <a:t>• Overall Median Latency: 2.82 Years (1,087d IQR) across 51,007 observations (536 genes)</a:t>
             </a:r>
             <a:br/>
             <a:r>
-              <a:t>• Cumulative Patient-Years at Risk: 202.5 Years across active uncorrected findings</a:t>
+              <a:t>• Cumulative Patient-Years at Risk: 182,760.4 Years across 51,251 findings</a:t>
             </a:r>
             <a:br/>
             <a:r>
-              <a:t>• Subgroup Kinetics: Class A Refuted (6.22 yrs) vs Class B Limited (5.10 yrs, p &lt; 0.001)</a:t>
+              <a:t>• Submitter Kinetics: Class A Refuted (2.80 yrs) vs Class B Limited (3.77 yrs, p &lt; 0.001)</a:t>
             </a:r>
           </a:p>
         </p:txBody>
       </p:sp>
       <p:pic>
         <p:nvPicPr>
-          <p:cNvPr id="10" name="Picture 9" descr="cropped_s6_latency_cdf_curve.png"/>
+          <p:cNvPr id="10" name="Picture 9" descr="cropped_s24_full_corpus_discrepancy_strata.png"/>
           <p:cNvPicPr>
             <a:picLocks noChangeAspect="1"/>
           </p:cNvPicPr>

</xml_diff>

<commit_message>
fix(pptx): resolve ECMA-376 schema violation and verify clean opening in Microsoft PowerPoint without repair prompt
</commit_message>
<xml_diff>
--- a/CuraCascade_Presentation_Redesigned.pptx
+++ b/CuraCascade_Presentation_Redesigned.pptx
@@ -6554,9 +6554,6 @@
 
 <file path=ppt/slides/slide1.xml><?xml version="1.0" encoding="utf-8"?>
 <p:sld xmlns:a="http://schemas.openxmlformats.org/drawingml/2006/main" xmlns:p="http://schemas.openxmlformats.org/presentationml/2006/main" xmlns:r="http://schemas.openxmlformats.org/officeDocument/2006/relationships">
-  <p:transition spd="med">
-    <p:fade/>
-  </p:transition>
   <p:cSld>
     <p:bg>
       <p:bgPr>
@@ -7060,14 +7057,14 @@
   <p:clrMapOvr>
     <a:masterClrMapping/>
   </p:clrMapOvr>
+  <p:transition spd="med">
+    <p:fade/>
+  </p:transition>
 </p:sld>
 </file>
 
 <file path=ppt/slides/slide10.xml><?xml version="1.0" encoding="utf-8"?>
 <p:sld xmlns:a="http://schemas.openxmlformats.org/drawingml/2006/main" xmlns:p="http://schemas.openxmlformats.org/presentationml/2006/main" xmlns:r="http://schemas.openxmlformats.org/officeDocument/2006/relationships">
-  <p:transition spd="med">
-    <p:fade/>
-  </p:transition>
   <p:cSld>
     <p:bg>
       <p:bgPr>
@@ -7607,14 +7604,14 @@
   <p:clrMapOvr>
     <a:masterClrMapping/>
   </p:clrMapOvr>
+  <p:transition spd="med">
+    <p:fade/>
+  </p:transition>
 </p:sld>
 </file>
 
 <file path=ppt/slides/slide11.xml><?xml version="1.0" encoding="utf-8"?>
 <p:sld xmlns:a="http://schemas.openxmlformats.org/drawingml/2006/main" xmlns:p="http://schemas.openxmlformats.org/presentationml/2006/main" xmlns:r="http://schemas.openxmlformats.org/officeDocument/2006/relationships">
-  <p:transition spd="med">
-    <p:fade/>
-  </p:transition>
   <p:cSld>
     <p:bg>
       <p:bgPr>
@@ -8454,14 +8451,14 @@
   <p:clrMapOvr>
     <a:masterClrMapping/>
   </p:clrMapOvr>
+  <p:transition spd="med">
+    <p:fade/>
+  </p:transition>
 </p:sld>
 </file>
 
 <file path=ppt/slides/slide12.xml><?xml version="1.0" encoding="utf-8"?>
 <p:sld xmlns:a="http://schemas.openxmlformats.org/drawingml/2006/main" xmlns:p="http://schemas.openxmlformats.org/presentationml/2006/main" xmlns:r="http://schemas.openxmlformats.org/officeDocument/2006/relationships">
-  <p:transition spd="med">
-    <p:fade/>
-  </p:transition>
   <p:cSld>
     <p:bg>
       <p:bgPr>
@@ -8883,14 +8880,14 @@
   <p:clrMapOvr>
     <a:masterClrMapping/>
   </p:clrMapOvr>
+  <p:transition spd="med">
+    <p:fade/>
+  </p:transition>
 </p:sld>
 </file>
 
 <file path=ppt/slides/slide13.xml><?xml version="1.0" encoding="utf-8"?>
 <p:sld xmlns:a="http://schemas.openxmlformats.org/drawingml/2006/main" xmlns:p="http://schemas.openxmlformats.org/presentationml/2006/main" xmlns:r="http://schemas.openxmlformats.org/officeDocument/2006/relationships">
-  <p:transition spd="med">
-    <p:fade/>
-  </p:transition>
   <p:cSld>
     <p:bg>
       <p:bgPr>
@@ -9339,14 +9336,14 @@
   <p:clrMapOvr>
     <a:masterClrMapping/>
   </p:clrMapOvr>
+  <p:transition spd="med">
+    <p:fade/>
+  </p:transition>
 </p:sld>
 </file>
 
 <file path=ppt/slides/slide14.xml><?xml version="1.0" encoding="utf-8"?>
 <p:sld xmlns:a="http://schemas.openxmlformats.org/drawingml/2006/main" xmlns:p="http://schemas.openxmlformats.org/presentationml/2006/main" xmlns:r="http://schemas.openxmlformats.org/officeDocument/2006/relationships">
-  <p:transition spd="med">
-    <p:fade/>
-  </p:transition>
   <p:cSld>
     <p:bg>
       <p:bgPr>
@@ -9949,14 +9946,14 @@
   <p:clrMapOvr>
     <a:masterClrMapping/>
   </p:clrMapOvr>
+  <p:transition spd="med">
+    <p:fade/>
+  </p:transition>
 </p:sld>
 </file>
 
 <file path=ppt/slides/slide15.xml><?xml version="1.0" encoding="utf-8"?>
 <p:sld xmlns:a="http://schemas.openxmlformats.org/drawingml/2006/main" xmlns:p="http://schemas.openxmlformats.org/presentationml/2006/main" xmlns:r="http://schemas.openxmlformats.org/officeDocument/2006/relationships">
-  <p:transition spd="med">
-    <p:fade/>
-  </p:transition>
   <p:cSld>
     <p:bg>
       <p:bgPr>
@@ -10701,14 +10698,14 @@
   <p:clrMapOvr>
     <a:masterClrMapping/>
   </p:clrMapOvr>
+  <p:transition spd="med">
+    <p:fade/>
+  </p:transition>
 </p:sld>
 </file>
 
 <file path=ppt/slides/slide16.xml><?xml version="1.0" encoding="utf-8"?>
 <p:sld xmlns:a="http://schemas.openxmlformats.org/drawingml/2006/main" xmlns:p="http://schemas.openxmlformats.org/presentationml/2006/main" xmlns:r="http://schemas.openxmlformats.org/officeDocument/2006/relationships">
-  <p:transition spd="med">
-    <p:fade/>
-  </p:transition>
   <p:cSld>
     <p:bg>
       <p:bgPr>
@@ -11157,14 +11154,14 @@
   <p:clrMapOvr>
     <a:masterClrMapping/>
   </p:clrMapOvr>
+  <p:transition spd="med">
+    <p:fade/>
+  </p:transition>
 </p:sld>
 </file>
 
 <file path=ppt/slides/slide17.xml><?xml version="1.0" encoding="utf-8"?>
 <p:sld xmlns:a="http://schemas.openxmlformats.org/drawingml/2006/main" xmlns:p="http://schemas.openxmlformats.org/presentationml/2006/main" xmlns:r="http://schemas.openxmlformats.org/officeDocument/2006/relationships">
-  <p:transition spd="med">
-    <p:fade/>
-  </p:transition>
   <p:cSld>
     <p:bg>
       <p:bgPr>
@@ -11586,14 +11583,14 @@
   <p:clrMapOvr>
     <a:masterClrMapping/>
   </p:clrMapOvr>
+  <p:transition spd="med">
+    <p:fade/>
+  </p:transition>
 </p:sld>
 </file>
 
 <file path=ppt/slides/slide18.xml><?xml version="1.0" encoding="utf-8"?>
 <p:sld xmlns:a="http://schemas.openxmlformats.org/drawingml/2006/main" xmlns:p="http://schemas.openxmlformats.org/presentationml/2006/main" xmlns:r="http://schemas.openxmlformats.org/officeDocument/2006/relationships">
-  <p:transition spd="med">
-    <p:fade/>
-  </p:transition>
   <p:cSld>
     <p:bg>
       <p:bgPr>
@@ -12015,14 +12012,14 @@
   <p:clrMapOvr>
     <a:masterClrMapping/>
   </p:clrMapOvr>
+  <p:transition spd="med">
+    <p:fade/>
+  </p:transition>
 </p:sld>
 </file>
 
 <file path=ppt/slides/slide19.xml><?xml version="1.0" encoding="utf-8"?>
 <p:sld xmlns:a="http://schemas.openxmlformats.org/drawingml/2006/main" xmlns:p="http://schemas.openxmlformats.org/presentationml/2006/main" xmlns:r="http://schemas.openxmlformats.org/officeDocument/2006/relationships">
-  <p:transition spd="med">
-    <p:fade/>
-  </p:transition>
   <p:cSld>
     <p:bg>
       <p:bgPr>
@@ -12617,14 +12614,14 @@
   <p:clrMapOvr>
     <a:masterClrMapping/>
   </p:clrMapOvr>
+  <p:transition spd="med">
+    <p:fade/>
+  </p:transition>
 </p:sld>
 </file>
 
 <file path=ppt/slides/slide2.xml><?xml version="1.0" encoding="utf-8"?>
 <p:sld xmlns:a="http://schemas.openxmlformats.org/drawingml/2006/main" xmlns:p="http://schemas.openxmlformats.org/presentationml/2006/main" xmlns:r="http://schemas.openxmlformats.org/officeDocument/2006/relationships">
-  <p:transition spd="med">
-    <p:fade/>
-  </p:transition>
   <p:cSld>
     <p:bg>
       <p:bgPr>
@@ -13574,14 +13571,14 @@
   <p:clrMapOvr>
     <a:masterClrMapping/>
   </p:clrMapOvr>
+  <p:transition spd="med">
+    <p:fade/>
+  </p:transition>
 </p:sld>
 </file>
 
 <file path=ppt/slides/slide20.xml><?xml version="1.0" encoding="utf-8"?>
 <p:sld xmlns:a="http://schemas.openxmlformats.org/drawingml/2006/main" xmlns:p="http://schemas.openxmlformats.org/presentationml/2006/main" xmlns:r="http://schemas.openxmlformats.org/officeDocument/2006/relationships">
-  <p:transition spd="med">
-    <p:fade/>
-  </p:transition>
   <p:cSld>
     <p:bg>
       <p:bgPr>
@@ -14121,14 +14118,14 @@
   <p:clrMapOvr>
     <a:masterClrMapping/>
   </p:clrMapOvr>
+  <p:transition spd="med">
+    <p:fade/>
+  </p:transition>
 </p:sld>
 </file>
 
 <file path=ppt/slides/slide21.xml><?xml version="1.0" encoding="utf-8"?>
 <p:sld xmlns:a="http://schemas.openxmlformats.org/drawingml/2006/main" xmlns:p="http://schemas.openxmlformats.org/presentationml/2006/main" xmlns:r="http://schemas.openxmlformats.org/officeDocument/2006/relationships">
-  <p:transition spd="med">
-    <p:fade/>
-  </p:transition>
   <p:cSld>
     <p:bg>
       <p:bgPr>
@@ -15164,14 +15161,14 @@
   <p:clrMapOvr>
     <a:masterClrMapping/>
   </p:clrMapOvr>
+  <p:transition spd="med">
+    <p:fade/>
+  </p:transition>
 </p:sld>
 </file>
 
 <file path=ppt/slides/slide22.xml><?xml version="1.0" encoding="utf-8"?>
 <p:sld xmlns:a="http://schemas.openxmlformats.org/drawingml/2006/main" xmlns:p="http://schemas.openxmlformats.org/presentationml/2006/main" xmlns:r="http://schemas.openxmlformats.org/officeDocument/2006/relationships">
-  <p:transition spd="med">
-    <p:fade/>
-  </p:transition>
   <p:cSld>
     <p:bg>
       <p:bgPr>
@@ -15711,14 +15708,14 @@
   <p:clrMapOvr>
     <a:masterClrMapping/>
   </p:clrMapOvr>
+  <p:transition spd="med">
+    <p:fade/>
+  </p:transition>
 </p:sld>
 </file>
 
 <file path=ppt/slides/slide23.xml><?xml version="1.0" encoding="utf-8"?>
 <p:sld xmlns:a="http://schemas.openxmlformats.org/drawingml/2006/main" xmlns:p="http://schemas.openxmlformats.org/presentationml/2006/main" xmlns:r="http://schemas.openxmlformats.org/officeDocument/2006/relationships">
-  <p:transition spd="med">
-    <p:fade/>
-  </p:transition>
   <p:cSld>
     <p:bg>
       <p:bgPr>
@@ -16277,14 +16274,14 @@
   <p:clrMapOvr>
     <a:masterClrMapping/>
   </p:clrMapOvr>
+  <p:transition spd="med">
+    <p:fade/>
+  </p:transition>
 </p:sld>
 </file>
 
 <file path=ppt/slides/slide24.xml><?xml version="1.0" encoding="utf-8"?>
 <p:sld xmlns:a="http://schemas.openxmlformats.org/drawingml/2006/main" xmlns:p="http://schemas.openxmlformats.org/presentationml/2006/main" xmlns:r="http://schemas.openxmlformats.org/officeDocument/2006/relationships">
-  <p:transition spd="med">
-    <p:fade/>
-  </p:transition>
   <p:cSld>
     <p:bg>
       <p:bgPr>
@@ -17074,14 +17071,14 @@
   <p:clrMapOvr>
     <a:masterClrMapping/>
   </p:clrMapOvr>
+  <p:transition spd="med">
+    <p:fade/>
+  </p:transition>
 </p:sld>
 </file>
 
 <file path=ppt/slides/slide25.xml><?xml version="1.0" encoding="utf-8"?>
 <p:sld xmlns:a="http://schemas.openxmlformats.org/drawingml/2006/main" xmlns:p="http://schemas.openxmlformats.org/presentationml/2006/main" xmlns:r="http://schemas.openxmlformats.org/officeDocument/2006/relationships">
-  <p:transition spd="med">
-    <p:fade/>
-  </p:transition>
   <p:cSld>
     <p:bg>
       <p:bgPr>
@@ -17700,14 +17697,14 @@
   <p:clrMapOvr>
     <a:masterClrMapping/>
   </p:clrMapOvr>
+  <p:transition spd="med">
+    <p:fade/>
+  </p:transition>
 </p:sld>
 </file>
 
 <file path=ppt/slides/slide3.xml><?xml version="1.0" encoding="utf-8"?>
 <p:sld xmlns:a="http://schemas.openxmlformats.org/drawingml/2006/main" xmlns:p="http://schemas.openxmlformats.org/presentationml/2006/main" xmlns:r="http://schemas.openxmlformats.org/officeDocument/2006/relationships">
-  <p:transition spd="med">
-    <p:fade/>
-  </p:transition>
   <p:cSld>
     <p:bg>
       <p:bgPr>
@@ -18266,14 +18263,14 @@
   <p:clrMapOvr>
     <a:masterClrMapping/>
   </p:clrMapOvr>
+  <p:transition spd="med">
+    <p:fade/>
+  </p:transition>
 </p:sld>
 </file>
 
 <file path=ppt/slides/slide4.xml><?xml version="1.0" encoding="utf-8"?>
 <p:sld xmlns:a="http://schemas.openxmlformats.org/drawingml/2006/main" xmlns:p="http://schemas.openxmlformats.org/presentationml/2006/main" xmlns:r="http://schemas.openxmlformats.org/officeDocument/2006/relationships">
-  <p:transition spd="med">
-    <p:fade/>
-  </p:transition>
   <p:cSld>
     <p:bg>
       <p:bgPr>
@@ -19018,14 +19015,14 @@
   <p:clrMapOvr>
     <a:masterClrMapping/>
   </p:clrMapOvr>
+  <p:transition spd="med">
+    <p:fade/>
+  </p:transition>
 </p:sld>
 </file>
 
 <file path=ppt/slides/slide5.xml><?xml version="1.0" encoding="utf-8"?>
 <p:sld xmlns:a="http://schemas.openxmlformats.org/drawingml/2006/main" xmlns:p="http://schemas.openxmlformats.org/presentationml/2006/main" xmlns:r="http://schemas.openxmlformats.org/officeDocument/2006/relationships">
-  <p:transition spd="med">
-    <p:fade/>
-  </p:transition>
   <p:cSld>
     <p:bg>
       <p:bgPr>
@@ -19625,14 +19622,14 @@
   <p:clrMapOvr>
     <a:masterClrMapping/>
   </p:clrMapOvr>
+  <p:transition spd="med">
+    <p:fade/>
+  </p:transition>
 </p:sld>
 </file>
 
 <file path=ppt/slides/slide6.xml><?xml version="1.0" encoding="utf-8"?>
 <p:sld xmlns:a="http://schemas.openxmlformats.org/drawingml/2006/main" xmlns:p="http://schemas.openxmlformats.org/presentationml/2006/main" xmlns:r="http://schemas.openxmlformats.org/officeDocument/2006/relationships">
-  <p:transition spd="med">
-    <p:fade/>
-  </p:transition>
   <p:cSld>
     <p:bg>
       <p:bgPr>
@@ -20497,14 +20494,14 @@
   <p:clrMapOvr>
     <a:masterClrMapping/>
   </p:clrMapOvr>
+  <p:transition spd="med">
+    <p:fade/>
+  </p:transition>
 </p:sld>
 </file>
 
 <file path=ppt/slides/slide7.xml><?xml version="1.0" encoding="utf-8"?>
 <p:sld xmlns:a="http://schemas.openxmlformats.org/drawingml/2006/main" xmlns:p="http://schemas.openxmlformats.org/presentationml/2006/main" xmlns:r="http://schemas.openxmlformats.org/officeDocument/2006/relationships">
-  <p:transition spd="med">
-    <p:fade/>
-  </p:transition>
   <p:cSld>
     <p:bg>
       <p:bgPr>
@@ -21109,14 +21106,14 @@
   <p:clrMapOvr>
     <a:masterClrMapping/>
   </p:clrMapOvr>
+  <p:transition spd="med">
+    <p:fade/>
+  </p:transition>
 </p:sld>
 </file>
 
 <file path=ppt/slides/slide8.xml><?xml version="1.0" encoding="utf-8"?>
 <p:sld xmlns:a="http://schemas.openxmlformats.org/drawingml/2006/main" xmlns:p="http://schemas.openxmlformats.org/presentationml/2006/main" xmlns:r="http://schemas.openxmlformats.org/officeDocument/2006/relationships">
-  <p:transition spd="med">
-    <p:fade/>
-  </p:transition>
   <p:cSld>
     <p:bg>
       <p:bgPr>
@@ -22224,14 +22221,14 @@
   <p:clrMapOvr>
     <a:masterClrMapping/>
   </p:clrMapOvr>
+  <p:transition spd="med">
+    <p:fade/>
+  </p:transition>
 </p:sld>
 </file>
 
 <file path=ppt/slides/slide9.xml><?xml version="1.0" encoding="utf-8"?>
 <p:sld xmlns:a="http://schemas.openxmlformats.org/drawingml/2006/main" xmlns:p="http://schemas.openxmlformats.org/presentationml/2006/main" xmlns:r="http://schemas.openxmlformats.org/officeDocument/2006/relationships">
-  <p:transition spd="med">
-    <p:fade/>
-  </p:transition>
   <p:cSld>
     <p:bg>
       <p:bgPr>
@@ -22826,6 +22823,9 @@
   <p:clrMapOvr>
     <a:masterClrMapping/>
   </p:clrMapOvr>
+  <p:transition spd="med">
+    <p:fade/>
+  </p:transition>
 </p:sld>
 </file>
 

</xml_diff>